<commit_message>
Complete CP5 validation and feedback updates
</commit_message>
<xml_diff>
--- a/demo-slides.pptx
+++ b/demo-slides.pptx
@@ -2,18 +2,18 @@
 <file path=ppt/presentation.xml><?xml version="1.0" encoding="utf-8"?>
 <p:presentation xmlns:p="http://schemas.openxmlformats.org/presentationml/2006/main">
   <p:sldMasterIdLst>
-    <p:sldMasterId xmlns:r="http://schemas.openxmlformats.org/officeDocument/2006/relationships" id="2147483648" r:id="R4141c9aececb4d12"/>
+    <p:sldMasterId xmlns:r="http://schemas.openxmlformats.org/officeDocument/2006/relationships" id="2147483648" r:id="Ra1e2906248f448d2"/>
   </p:sldMasterIdLst>
   <p:notesMasterIdLst>
-    <p:notesMasterId xmlns:r="http://schemas.openxmlformats.org/officeDocument/2006/relationships" r:id="R48157fdd406d4508"/>
+    <p:notesMasterId xmlns:r="http://schemas.openxmlformats.org/officeDocument/2006/relationships" r:id="Rddb942f496574022"/>
   </p:notesMasterIdLst>
   <p:sldIdLst>
-    <p:sldId xmlns:r="http://schemas.openxmlformats.org/officeDocument/2006/relationships" id="256" r:id="R6432811a90634681"/>
-    <p:sldId xmlns:r="http://schemas.openxmlformats.org/officeDocument/2006/relationships" id="257" r:id="R439269ce91034ea3"/>
-    <p:sldId xmlns:r="http://schemas.openxmlformats.org/officeDocument/2006/relationships" id="258" r:id="Rf44802dcee0348a9"/>
-    <p:sldId xmlns:r="http://schemas.openxmlformats.org/officeDocument/2006/relationships" id="259" r:id="R7623adac090f4dd7"/>
-    <p:sldId xmlns:r="http://schemas.openxmlformats.org/officeDocument/2006/relationships" id="260" r:id="R9acf51b84d8c4167"/>
-    <p:sldId xmlns:r="http://schemas.openxmlformats.org/officeDocument/2006/relationships" id="261" r:id="Rb565b93a21b6473d"/>
+    <p:sldId xmlns:r="http://schemas.openxmlformats.org/officeDocument/2006/relationships" id="256" r:id="R5e718e4cc9ca4187"/>
+    <p:sldId xmlns:r="http://schemas.openxmlformats.org/officeDocument/2006/relationships" id="257" r:id="R49e195f4acc9459a"/>
+    <p:sldId xmlns:r="http://schemas.openxmlformats.org/officeDocument/2006/relationships" id="258" r:id="R458a315965e3408e"/>
+    <p:sldId xmlns:r="http://schemas.openxmlformats.org/officeDocument/2006/relationships" id="259" r:id="R2d50d66594094965"/>
+    <p:sldId xmlns:r="http://schemas.openxmlformats.org/officeDocument/2006/relationships" id="260" r:id="Ra11f8ebfb5fc4816"/>
+    <p:sldId xmlns:r="http://schemas.openxmlformats.org/officeDocument/2006/relationships" id="261" r:id="R9a1982e4a4664b7b"/>
   </p:sldIdLst>
   <p:sldSz cx="12192000" cy="6858000"/>
   <p:notesSz cx="6858000" cy="9144000"/>
@@ -852,12 +852,22 @@
           <a:lstStyle xmlns:a="http://schemas.openxmlformats.org/drawingml/2006/main"/>
           <a:p xmlns:a="http://schemas.openxmlformats.org/drawingml/2006/main">
             <a:r>
-              <a:t>Đây là slide blocker có chủ đích: tuyệt đối không trình bày placeholder như feedback thật.</a:t>
-            </a:r>
-          </a:p>
-          <a:p xmlns:a="http://schemas.openxmlformats.org/drawingml/2006/main">
-            <a:r>
-              <a:t>Sau 5 buổi test, thay 0/5, hai quote và quyết định thay đổi.</a:t>
+              <a:t>Kết quả thử với 5 người ngoài nhóm: 4/5 tự hoàn thành, 5/5 tin hoặc khá tin, 5/5 nói sẽ dùng thật.</a:t>
+            </a:r>
+          </a:p>
+          <a:p xmlns:a="http://schemas.openxmlformats.org/drawingml/2006/main">
+            <a:r>
+              <a:t>Hai lỗi rõ nhất là nút Kiểm tra tôi chưa nổi bật và các nhãn mastery khó phân biệt.</a:t>
+            </a:r>
+          </a:p>
+          <a:p xmlns:a="http://schemas.openxmlformats.org/drawingml/2006/main">
+            <a:r>
+              <a:t>Nhóm đã sửa trực tiếp hai điểm này trước demo.</a:t>
+            </a:r>
+          </a:p>
+          <a:p xmlns:a="http://schemas.openxmlformats.org/drawingml/2006/main">
+            <a:r>
+              <a:t>Dry run hiện là 5 phút 08 giây, vì vậy câu trả lời CP5 là đã chạy nhưng quá giờ.</a:t>
             </a:r>
           </a:p>
           <a:p xmlns:a="http://schemas.openxmlformats.org/drawingml/2006/main">
@@ -872,17 +882,17 @@
           </a:p>
           <a:p xmlns:a="http://schemas.openxmlformats.org/drawingml/2006/main">
             <a:r>
-              <a:t>- 02-guide.md §4.2–4.3 và §5.1</a:t>
-            </a:r>
-          </a:p>
-          <a:p xmlns:a="http://schemas.openxmlformats.org/drawingml/2006/main">
-            <a:r>
               <a:t>- validation/feedback-log.md</a:t>
             </a:r>
           </a:p>
           <a:p xmlns:a="http://schemas.openxmlformats.org/drawingml/2006/main">
             <a:r>
               <a:t>- validation/summary.md</a:t>
+            </a:r>
+          </a:p>
+          <a:p xmlns:a="http://schemas.openxmlformats.org/drawingml/2006/main">
+            <a:r>
+              <a:t>- validation/dry-run.md</a:t>
             </a:r>
           </a:p>
           <a:p xmlns:a="http://schemas.openxmlformats.org/drawingml/2006/main">
@@ -1060,7 +1070,7 @@
   </p:cSld>
   <p:clrMap bg1="lt1" tx1="dk1" bg2="lt2" tx2="dk2" accent1="accent1" accent2="accent2" accent3="accent3" accent4="accent4" accent5="accent5" accent6="accent6" hlink="hlink" folHlink="folHlink"/>
   <p:sldLayoutIdLst>
-    <p:sldLayoutId xmlns:r="http://schemas.openxmlformats.org/officeDocument/2006/relationships" id="2147483649" r:id="R280a6cbb40bb4524"/>
+    <p:sldLayoutId xmlns:r="http://schemas.openxmlformats.org/officeDocument/2006/relationships" id="2147483649" r:id="Rea90a5c231ff4a93"/>
   </p:sldLayoutIdLst>
   <p:txStyles>
     <p:titleStyle>
@@ -1672,6 +1682,7 @@
           <a:lstStyle xmlns:a="http://schemas.openxmlformats.org/drawingml/2006/main"/>
           <a:p xmlns:a="http://schemas.openxmlformats.org/drawingml/2006/main">
             <a:pPr algn="ctr">
+              <a:buNone/>
               <a:defRPr sz="1050" b="1">
                 <a:solidFill>
                   <a:srgbClr val="0B1628"/>
@@ -1722,6 +1733,7 @@
           <a:lstStyle xmlns:a="http://schemas.openxmlformats.org/drawingml/2006/main"/>
           <a:p xmlns:a="http://schemas.openxmlformats.org/drawingml/2006/main">
             <a:pPr algn="l">
+              <a:buNone/>
               <a:defRPr sz="3750" b="1">
                 <a:solidFill>
                   <a:srgbClr val="FFFFFF"/>
@@ -1739,6 +1751,7 @@
           </a:p>
           <a:p xmlns:a="http://schemas.openxmlformats.org/drawingml/2006/main">
             <a:pPr algn="l">
+              <a:buNone/>
               <a:defRPr sz="3750" b="1">
                 <a:solidFill>
                   <a:srgbClr val="FFFFFF"/>
@@ -1789,6 +1802,7 @@
           <a:lstStyle xmlns:a="http://schemas.openxmlformats.org/drawingml/2006/main"/>
           <a:p xmlns:a="http://schemas.openxmlformats.org/drawingml/2006/main">
             <a:pPr algn="l">
+              <a:buNone/>
               <a:defRPr sz="1800" b="0">
                 <a:solidFill>
                   <a:srgbClr val="B9F4ED"/>
@@ -1872,6 +1886,7 @@
           <a:lstStyle xmlns:a="http://schemas.openxmlformats.org/drawingml/2006/main"/>
           <a:p xmlns:a="http://schemas.openxmlformats.org/drawingml/2006/main">
             <a:pPr algn="l">
+              <a:buNone/>
               <a:defRPr sz="1050" b="1">
                 <a:solidFill>
                   <a:srgbClr val="64748B"/>
@@ -1922,6 +1937,7 @@
           <a:lstStyle xmlns:a="http://schemas.openxmlformats.org/drawingml/2006/main"/>
           <a:p xmlns:a="http://schemas.openxmlformats.org/drawingml/2006/main">
             <a:pPr algn="l">
+              <a:buNone/>
               <a:defRPr sz="5250" b="1">
                 <a:solidFill>
                   <a:srgbClr val="0B1628"/>
@@ -1972,6 +1988,7 @@
           <a:lstStyle xmlns:a="http://schemas.openxmlformats.org/drawingml/2006/main"/>
           <a:p xmlns:a="http://schemas.openxmlformats.org/drawingml/2006/main">
             <a:pPr algn="l">
+              <a:buNone/>
               <a:defRPr sz="1575" b="1">
                 <a:solidFill>
                   <a:srgbClr val="0B1628"/>
@@ -1989,6 +2006,7 @@
           </a:p>
           <a:p xmlns:a="http://schemas.openxmlformats.org/drawingml/2006/main">
             <a:pPr algn="l">
+              <a:buNone/>
               <a:defRPr sz="1575" b="1">
                 <a:solidFill>
                   <a:srgbClr val="0B1628"/>
@@ -2070,6 +2088,7 @@
           <a:lstStyle xmlns:a="http://schemas.openxmlformats.org/drawingml/2006/main"/>
           <a:p xmlns:a="http://schemas.openxmlformats.org/drawingml/2006/main">
             <a:pPr algn="l">
+              <a:buNone/>
               <a:defRPr sz="3750" b="1">
                 <a:solidFill>
                   <a:srgbClr val="FF9B5E"/>
@@ -2120,6 +2139,7 @@
           <a:lstStyle xmlns:a="http://schemas.openxmlformats.org/drawingml/2006/main"/>
           <a:p xmlns:a="http://schemas.openxmlformats.org/drawingml/2006/main">
             <a:pPr algn="l">
+              <a:buNone/>
               <a:defRPr sz="1350" b="0">
                 <a:solidFill>
                   <a:srgbClr val="64748B"/>
@@ -2137,6 +2157,7 @@
           </a:p>
           <a:p xmlns:a="http://schemas.openxmlformats.org/drawingml/2006/main">
             <a:pPr algn="l">
+              <a:buNone/>
               <a:defRPr sz="1350" b="0">
                 <a:solidFill>
                   <a:srgbClr val="64748B"/>
@@ -2220,6 +2241,7 @@
           <a:lstStyle xmlns:a="http://schemas.openxmlformats.org/drawingml/2006/main"/>
           <a:p xmlns:a="http://schemas.openxmlformats.org/drawingml/2006/main">
             <a:pPr algn="ctr">
+              <a:buNone/>
               <a:defRPr sz="1050" b="1">
                 <a:solidFill>
                   <a:srgbClr val="0B1628"/>
@@ -2270,6 +2292,7 @@
           <a:lstStyle xmlns:a="http://schemas.openxmlformats.org/drawingml/2006/main"/>
           <a:p xmlns:a="http://schemas.openxmlformats.org/drawingml/2006/main">
             <a:pPr algn="l">
+              <a:buNone/>
               <a:defRPr sz="1050" b="1">
                 <a:solidFill>
                   <a:srgbClr val="33D6C5"/>
@@ -2320,6 +2343,7 @@
           <a:lstStyle xmlns:a="http://schemas.openxmlformats.org/drawingml/2006/main"/>
           <a:p xmlns:a="http://schemas.openxmlformats.org/drawingml/2006/main">
             <a:pPr algn="l">
+              <a:buNone/>
               <a:defRPr sz="2100" b="1">
                 <a:solidFill>
                   <a:srgbClr val="FFFFFF"/>
@@ -2370,6 +2394,7 @@
           <a:lstStyle xmlns:a="http://schemas.openxmlformats.org/drawingml/2006/main"/>
           <a:p xmlns:a="http://schemas.openxmlformats.org/drawingml/2006/main">
             <a:pPr algn="l">
+              <a:buNone/>
               <a:defRPr sz="900" b="0">
                 <a:solidFill>
                   <a:srgbClr val="92A5BE"/>
@@ -2482,6 +2507,7 @@
           <a:lstStyle xmlns:a="http://schemas.openxmlformats.org/drawingml/2006/main"/>
           <a:p xmlns:a="http://schemas.openxmlformats.org/drawingml/2006/main">
             <a:pPr algn="ctr">
+              <a:buNone/>
               <a:defRPr sz="1050" b="1">
                 <a:solidFill>
                   <a:srgbClr val="FFFFFF"/>
@@ -2532,6 +2558,7 @@
           <a:lstStyle xmlns:a="http://schemas.openxmlformats.org/drawingml/2006/main"/>
           <a:p xmlns:a="http://schemas.openxmlformats.org/drawingml/2006/main">
             <a:pPr algn="l">
+              <a:buNone/>
               <a:defRPr sz="1050" b="1">
                 <a:solidFill>
                   <a:srgbClr val="64748B"/>
@@ -2582,6 +2609,7 @@
           <a:lstStyle xmlns:a="http://schemas.openxmlformats.org/drawingml/2006/main"/>
           <a:p xmlns:a="http://schemas.openxmlformats.org/drawingml/2006/main">
             <a:pPr algn="l">
+              <a:buNone/>
               <a:defRPr sz="2850" b="1">
                 <a:solidFill>
                   <a:srgbClr val="0B1628"/>
@@ -2632,6 +2660,7 @@
           <a:lstStyle xmlns:a="http://schemas.openxmlformats.org/drawingml/2006/main"/>
           <a:p xmlns:a="http://schemas.openxmlformats.org/drawingml/2006/main">
             <a:pPr algn="l">
+              <a:buNone/>
               <a:defRPr sz="1350" b="0">
                 <a:solidFill>
                   <a:srgbClr val="64748B"/>
@@ -2750,6 +2779,7 @@
           <a:lstStyle xmlns:a="http://schemas.openxmlformats.org/drawingml/2006/main"/>
           <a:p xmlns:a="http://schemas.openxmlformats.org/drawingml/2006/main">
             <a:pPr algn="ctr">
+              <a:buNone/>
               <a:defRPr sz="1050" b="1">
                 <a:solidFill>
                   <a:srgbClr val="FFFFFF"/>
@@ -2800,6 +2830,7 @@
           <a:lstStyle xmlns:a="http://schemas.openxmlformats.org/drawingml/2006/main"/>
           <a:p xmlns:a="http://schemas.openxmlformats.org/drawingml/2006/main">
             <a:pPr algn="l">
+              <a:buNone/>
               <a:defRPr sz="1950" b="1">
                 <a:solidFill>
                   <a:srgbClr val="0B1628"/>
@@ -2850,6 +2881,7 @@
           <a:lstStyle xmlns:a="http://schemas.openxmlformats.org/drawingml/2006/main"/>
           <a:p xmlns:a="http://schemas.openxmlformats.org/drawingml/2006/main">
             <a:pPr algn="l">
+              <a:buNone/>
               <a:defRPr sz="3300" b="1">
                 <a:solidFill>
                   <a:srgbClr val="64748B"/>
@@ -2900,6 +2932,7 @@
           <a:lstStyle xmlns:a="http://schemas.openxmlformats.org/drawingml/2006/main"/>
           <a:p xmlns:a="http://schemas.openxmlformats.org/drawingml/2006/main">
             <a:pPr algn="l">
+              <a:buNone/>
               <a:defRPr sz="1575" b="0">
                 <a:solidFill>
                   <a:srgbClr val="64748B"/>
@@ -2917,6 +2950,7 @@
           </a:p>
           <a:p xmlns:a="http://schemas.openxmlformats.org/drawingml/2006/main">
             <a:pPr algn="l">
+              <a:buNone/>
               <a:defRPr sz="1575" b="0">
                 <a:solidFill>
                   <a:srgbClr val="64748B"/>
@@ -3035,6 +3069,7 @@
           <a:lstStyle xmlns:a="http://schemas.openxmlformats.org/drawingml/2006/main"/>
           <a:p xmlns:a="http://schemas.openxmlformats.org/drawingml/2006/main">
             <a:pPr algn="ctr">
+              <a:buNone/>
               <a:defRPr sz="1050" b="1">
                 <a:solidFill>
                   <a:srgbClr val="FFFFFF"/>
@@ -3085,6 +3120,7 @@
           <a:lstStyle xmlns:a="http://schemas.openxmlformats.org/drawingml/2006/main"/>
           <a:p xmlns:a="http://schemas.openxmlformats.org/drawingml/2006/main">
             <a:pPr algn="l">
+              <a:buNone/>
               <a:defRPr sz="1950" b="1">
                 <a:solidFill>
                   <a:srgbClr val="0B1628"/>
@@ -3135,6 +3171,7 @@
           <a:lstStyle xmlns:a="http://schemas.openxmlformats.org/drawingml/2006/main"/>
           <a:p xmlns:a="http://schemas.openxmlformats.org/drawingml/2006/main">
             <a:pPr algn="l">
+              <a:buNone/>
               <a:defRPr sz="3300" b="1">
                 <a:solidFill>
                   <a:srgbClr val="FF9B5E"/>
@@ -3185,6 +3222,7 @@
           <a:lstStyle xmlns:a="http://schemas.openxmlformats.org/drawingml/2006/main"/>
           <a:p xmlns:a="http://schemas.openxmlformats.org/drawingml/2006/main">
             <a:pPr algn="l">
+              <a:buNone/>
               <a:defRPr sz="1575" b="0">
                 <a:solidFill>
                   <a:srgbClr val="64748B"/>
@@ -3202,6 +3240,7 @@
           </a:p>
           <a:p xmlns:a="http://schemas.openxmlformats.org/drawingml/2006/main">
             <a:pPr algn="l">
+              <a:buNone/>
               <a:defRPr sz="1575" b="0">
                 <a:solidFill>
                   <a:srgbClr val="64748B"/>
@@ -3320,6 +3359,7 @@
           <a:lstStyle xmlns:a="http://schemas.openxmlformats.org/drawingml/2006/main"/>
           <a:p xmlns:a="http://schemas.openxmlformats.org/drawingml/2006/main">
             <a:pPr algn="ctr">
+              <a:buNone/>
               <a:defRPr sz="1050" b="1">
                 <a:solidFill>
                   <a:srgbClr val="0B1628"/>
@@ -3370,6 +3410,7 @@
           <a:lstStyle xmlns:a="http://schemas.openxmlformats.org/drawingml/2006/main"/>
           <a:p xmlns:a="http://schemas.openxmlformats.org/drawingml/2006/main">
             <a:pPr algn="l">
+              <a:buNone/>
               <a:defRPr sz="1950" b="1">
                 <a:solidFill>
                   <a:srgbClr val="FFFFFF"/>
@@ -3420,6 +3461,7 @@
           <a:lstStyle xmlns:a="http://schemas.openxmlformats.org/drawingml/2006/main"/>
           <a:p xmlns:a="http://schemas.openxmlformats.org/drawingml/2006/main">
             <a:pPr algn="l">
+              <a:buNone/>
               <a:defRPr sz="3300" b="1">
                 <a:solidFill>
                   <a:srgbClr val="33D6C5"/>
@@ -3470,6 +3512,7 @@
           <a:lstStyle xmlns:a="http://schemas.openxmlformats.org/drawingml/2006/main"/>
           <a:p xmlns:a="http://schemas.openxmlformats.org/drawingml/2006/main">
             <a:pPr algn="l">
+              <a:buNone/>
               <a:defRPr sz="1575" b="0">
                 <a:solidFill>
                   <a:srgbClr val="B9F4ED"/>
@@ -3487,6 +3530,7 @@
           </a:p>
           <a:p xmlns:a="http://schemas.openxmlformats.org/drawingml/2006/main">
             <a:pPr algn="l">
+              <a:buNone/>
               <a:defRPr sz="1575" b="0">
                 <a:solidFill>
                   <a:srgbClr val="B9F4ED"/>
@@ -3537,6 +3581,7 @@
           <a:lstStyle xmlns:a="http://schemas.openxmlformats.org/drawingml/2006/main"/>
           <a:p xmlns:a="http://schemas.openxmlformats.org/drawingml/2006/main">
             <a:pPr algn="l">
+              <a:buNone/>
               <a:defRPr sz="900" b="0">
                 <a:solidFill>
                   <a:srgbClr val="64748B"/>
@@ -3649,6 +3694,7 @@
           <a:lstStyle xmlns:a="http://schemas.openxmlformats.org/drawingml/2006/main"/>
           <a:p xmlns:a="http://schemas.openxmlformats.org/drawingml/2006/main">
             <a:pPr algn="ctr">
+              <a:buNone/>
               <a:defRPr sz="1050" b="1">
                 <a:solidFill>
                   <a:srgbClr val="FFFFFF"/>
@@ -3699,6 +3745,7 @@
           <a:lstStyle xmlns:a="http://schemas.openxmlformats.org/drawingml/2006/main"/>
           <a:p xmlns:a="http://schemas.openxmlformats.org/drawingml/2006/main">
             <a:pPr algn="l">
+              <a:buNone/>
               <a:defRPr sz="1050" b="1">
                 <a:solidFill>
                   <a:srgbClr val="64748B"/>
@@ -3749,6 +3796,7 @@
           <a:lstStyle xmlns:a="http://schemas.openxmlformats.org/drawingml/2006/main"/>
           <a:p xmlns:a="http://schemas.openxmlformats.org/drawingml/2006/main">
             <a:pPr algn="l">
+              <a:buNone/>
               <a:defRPr sz="2850" b="1">
                 <a:solidFill>
                   <a:srgbClr val="0B1628"/>
@@ -3799,6 +3847,7 @@
           <a:lstStyle xmlns:a="http://schemas.openxmlformats.org/drawingml/2006/main"/>
           <a:p xmlns:a="http://schemas.openxmlformats.org/drawingml/2006/main">
             <a:pPr algn="l">
+              <a:buNone/>
               <a:defRPr sz="1350" b="0">
                 <a:solidFill>
                   <a:srgbClr val="64748B"/>
@@ -3917,6 +3966,7 @@
           <a:lstStyle xmlns:a="http://schemas.openxmlformats.org/drawingml/2006/main"/>
           <a:p xmlns:a="http://schemas.openxmlformats.org/drawingml/2006/main">
             <a:pPr algn="ctr">
+              <a:buNone/>
               <a:defRPr sz="1050" b="1">
                 <a:solidFill>
                   <a:srgbClr val="0B1628"/>
@@ -3967,6 +4017,7 @@
           <a:lstStyle xmlns:a="http://schemas.openxmlformats.org/drawingml/2006/main"/>
           <a:p xmlns:a="http://schemas.openxmlformats.org/drawingml/2006/main">
             <a:pPr algn="l">
+              <a:buNone/>
               <a:defRPr sz="1800" b="1">
                 <a:solidFill>
                   <a:srgbClr val="0B1628"/>
@@ -4017,6 +4068,7 @@
           <a:lstStyle xmlns:a="http://schemas.openxmlformats.org/drawingml/2006/main"/>
           <a:p xmlns:a="http://schemas.openxmlformats.org/drawingml/2006/main">
             <a:pPr algn="l">
+              <a:buNone/>
               <a:defRPr sz="1275" b="0">
                 <a:solidFill>
                   <a:srgbClr val="64748B"/>
@@ -4067,6 +4119,7 @@
           <a:lstStyle xmlns:a="http://schemas.openxmlformats.org/drawingml/2006/main"/>
           <a:p xmlns:a="http://schemas.openxmlformats.org/drawingml/2006/main">
             <a:pPr algn="ctr">
+              <a:buNone/>
               <a:defRPr sz="2100" b="1">
                 <a:solidFill>
                   <a:srgbClr val="64748B"/>
@@ -4185,6 +4238,7 @@
           <a:lstStyle xmlns:a="http://schemas.openxmlformats.org/drawingml/2006/main"/>
           <a:p xmlns:a="http://schemas.openxmlformats.org/drawingml/2006/main">
             <a:pPr algn="ctr">
+              <a:buNone/>
               <a:defRPr sz="1050" b="1">
                 <a:solidFill>
                   <a:srgbClr val="0B1628"/>
@@ -4235,6 +4289,7 @@
           <a:lstStyle xmlns:a="http://schemas.openxmlformats.org/drawingml/2006/main"/>
           <a:p xmlns:a="http://schemas.openxmlformats.org/drawingml/2006/main">
             <a:pPr algn="l">
+              <a:buNone/>
               <a:defRPr sz="1800" b="1">
                 <a:solidFill>
                   <a:srgbClr val="0B1628"/>
@@ -4285,6 +4340,7 @@
           <a:lstStyle xmlns:a="http://schemas.openxmlformats.org/drawingml/2006/main"/>
           <a:p xmlns:a="http://schemas.openxmlformats.org/drawingml/2006/main">
             <a:pPr algn="l">
+              <a:buNone/>
               <a:defRPr sz="1275" b="0">
                 <a:solidFill>
                   <a:srgbClr val="64748B"/>
@@ -4335,6 +4391,7 @@
           <a:lstStyle xmlns:a="http://schemas.openxmlformats.org/drawingml/2006/main"/>
           <a:p xmlns:a="http://schemas.openxmlformats.org/drawingml/2006/main">
             <a:pPr algn="ctr">
+              <a:buNone/>
               <a:defRPr sz="2100" b="1">
                 <a:solidFill>
                   <a:srgbClr val="64748B"/>
@@ -4453,6 +4510,7 @@
           <a:lstStyle xmlns:a="http://schemas.openxmlformats.org/drawingml/2006/main"/>
           <a:p xmlns:a="http://schemas.openxmlformats.org/drawingml/2006/main">
             <a:pPr algn="ctr">
+              <a:buNone/>
               <a:defRPr sz="1050" b="1">
                 <a:solidFill>
                   <a:srgbClr val="0B1628"/>
@@ -4503,6 +4561,7 @@
           <a:lstStyle xmlns:a="http://schemas.openxmlformats.org/drawingml/2006/main"/>
           <a:p xmlns:a="http://schemas.openxmlformats.org/drawingml/2006/main">
             <a:pPr algn="l">
+              <a:buNone/>
               <a:defRPr sz="1800" b="1">
                 <a:solidFill>
                   <a:srgbClr val="FFFFFF"/>
@@ -4553,6 +4612,7 @@
           <a:lstStyle xmlns:a="http://schemas.openxmlformats.org/drawingml/2006/main"/>
           <a:p xmlns:a="http://schemas.openxmlformats.org/drawingml/2006/main">
             <a:pPr algn="l">
+              <a:buNone/>
               <a:defRPr sz="1275" b="0">
                 <a:solidFill>
                   <a:srgbClr val="B9F4ED"/>
@@ -4603,6 +4663,7 @@
           <a:lstStyle xmlns:a="http://schemas.openxmlformats.org/drawingml/2006/main"/>
           <a:p xmlns:a="http://schemas.openxmlformats.org/drawingml/2006/main">
             <a:pPr algn="ctr">
+              <a:buNone/>
               <a:defRPr sz="2100" b="1">
                 <a:solidFill>
                   <a:srgbClr val="64748B"/>
@@ -4721,6 +4782,7 @@
           <a:lstStyle xmlns:a="http://schemas.openxmlformats.org/drawingml/2006/main"/>
           <a:p xmlns:a="http://schemas.openxmlformats.org/drawingml/2006/main">
             <a:pPr algn="ctr">
+              <a:buNone/>
               <a:defRPr sz="1050" b="1">
                 <a:solidFill>
                   <a:srgbClr val="0B1628"/>
@@ -4771,6 +4833,7 @@
           <a:lstStyle xmlns:a="http://schemas.openxmlformats.org/drawingml/2006/main"/>
           <a:p xmlns:a="http://schemas.openxmlformats.org/drawingml/2006/main">
             <a:pPr algn="l">
+              <a:buNone/>
               <a:defRPr sz="1800" b="1">
                 <a:solidFill>
                   <a:srgbClr val="0B1628"/>
@@ -4821,6 +4884,7 @@
           <a:lstStyle xmlns:a="http://schemas.openxmlformats.org/drawingml/2006/main"/>
           <a:p xmlns:a="http://schemas.openxmlformats.org/drawingml/2006/main">
             <a:pPr algn="l">
+              <a:buNone/>
               <a:defRPr sz="1275" b="0">
                 <a:solidFill>
                   <a:srgbClr val="64748B"/>
@@ -4939,6 +5003,7 @@
           <a:lstStyle xmlns:a="http://schemas.openxmlformats.org/drawingml/2006/main"/>
           <a:p xmlns:a="http://schemas.openxmlformats.org/drawingml/2006/main">
             <a:pPr algn="ctr">
+              <a:buNone/>
               <a:defRPr sz="1050" b="1">
                 <a:solidFill>
                   <a:srgbClr val="FFFFFF"/>
@@ -4989,6 +5054,7 @@
           <a:lstStyle xmlns:a="http://schemas.openxmlformats.org/drawingml/2006/main"/>
           <a:p xmlns:a="http://schemas.openxmlformats.org/drawingml/2006/main">
             <a:pPr algn="l">
+              <a:buNone/>
               <a:defRPr sz="1575" b="1">
                 <a:solidFill>
                   <a:srgbClr val="0B1628"/>
@@ -5039,6 +5105,7 @@
           <a:lstStyle xmlns:a="http://schemas.openxmlformats.org/drawingml/2006/main"/>
           <a:p xmlns:a="http://schemas.openxmlformats.org/drawingml/2006/main">
             <a:pPr algn="l">
+              <a:buNone/>
               <a:defRPr sz="1350" b="1">
                 <a:solidFill>
                   <a:srgbClr val="1EAA72"/>
@@ -5155,6 +5222,7 @@
           <a:lstStyle xmlns:a="http://schemas.openxmlformats.org/drawingml/2006/main"/>
           <a:p xmlns:a="http://schemas.openxmlformats.org/drawingml/2006/main">
             <a:pPr algn="ctr">
+              <a:buNone/>
               <a:defRPr sz="1050" b="1">
                 <a:solidFill>
                   <a:srgbClr val="0B1628"/>
@@ -5205,6 +5273,7 @@
           <a:lstStyle xmlns:a="http://schemas.openxmlformats.org/drawingml/2006/main"/>
           <a:p xmlns:a="http://schemas.openxmlformats.org/drawingml/2006/main">
             <a:pPr algn="l">
+              <a:buNone/>
               <a:defRPr sz="1575" b="1">
                 <a:solidFill>
                   <a:srgbClr val="FFFFFF"/>
@@ -5255,6 +5324,7 @@
           <a:lstStyle xmlns:a="http://schemas.openxmlformats.org/drawingml/2006/main"/>
           <a:p xmlns:a="http://schemas.openxmlformats.org/drawingml/2006/main">
             <a:pPr algn="l">
+              <a:buNone/>
               <a:defRPr sz="1350" b="1">
                 <a:solidFill>
                   <a:srgbClr val="33D6C5"/>
@@ -5305,6 +5375,7 @@
           <a:lstStyle xmlns:a="http://schemas.openxmlformats.org/drawingml/2006/main"/>
           <a:p xmlns:a="http://schemas.openxmlformats.org/drawingml/2006/main">
             <a:pPr algn="l">
+              <a:buNone/>
               <a:defRPr sz="900" b="0">
                 <a:solidFill>
                   <a:srgbClr val="64748B"/>
@@ -5417,6 +5488,7 @@
           <a:lstStyle xmlns:a="http://schemas.openxmlformats.org/drawingml/2006/main"/>
           <a:p xmlns:a="http://schemas.openxmlformats.org/drawingml/2006/main">
             <a:pPr algn="ctr">
+              <a:buNone/>
               <a:defRPr sz="1050" b="1">
                 <a:solidFill>
                   <a:srgbClr val="FFFFFF"/>
@@ -5467,6 +5539,7 @@
           <a:lstStyle xmlns:a="http://schemas.openxmlformats.org/drawingml/2006/main"/>
           <a:p xmlns:a="http://schemas.openxmlformats.org/drawingml/2006/main">
             <a:pPr algn="l">
+              <a:buNone/>
               <a:defRPr sz="1050" b="1">
                 <a:solidFill>
                   <a:srgbClr val="64748B"/>
@@ -5517,6 +5590,7 @@
           <a:lstStyle xmlns:a="http://schemas.openxmlformats.org/drawingml/2006/main"/>
           <a:p xmlns:a="http://schemas.openxmlformats.org/drawingml/2006/main">
             <a:pPr algn="l">
+              <a:buNone/>
               <a:defRPr sz="2850" b="1">
                 <a:solidFill>
                   <a:srgbClr val="0B1628"/>
@@ -5567,6 +5641,7 @@
           <a:lstStyle xmlns:a="http://schemas.openxmlformats.org/drawingml/2006/main"/>
           <a:p xmlns:a="http://schemas.openxmlformats.org/drawingml/2006/main">
             <a:pPr algn="l">
+              <a:buNone/>
               <a:defRPr sz="1350" b="0">
                 <a:solidFill>
                   <a:srgbClr val="64748B"/>
@@ -5652,6 +5727,7 @@
           <a:lstStyle xmlns:a="http://schemas.openxmlformats.org/drawingml/2006/main"/>
           <a:p xmlns:a="http://schemas.openxmlformats.org/drawingml/2006/main">
             <a:pPr algn="l">
+              <a:buNone/>
               <a:defRPr sz="1050" b="1">
                 <a:solidFill>
                   <a:srgbClr val="64748B"/>
@@ -5735,6 +5811,7 @@
           <a:lstStyle xmlns:a="http://schemas.openxmlformats.org/drawingml/2006/main"/>
           <a:p xmlns:a="http://schemas.openxmlformats.org/drawingml/2006/main">
             <a:pPr algn="ctr">
+              <a:buNone/>
               <a:defRPr sz="1875" b="1">
                 <a:solidFill>
                   <a:srgbClr val="0B1628"/>
@@ -5785,6 +5862,7 @@
           <a:lstStyle xmlns:a="http://schemas.openxmlformats.org/drawingml/2006/main"/>
           <a:p xmlns:a="http://schemas.openxmlformats.org/drawingml/2006/main">
             <a:pPr algn="ctr">
+              <a:buNone/>
               <a:defRPr sz="1200" b="1">
                 <a:solidFill>
                   <a:srgbClr val="64748B"/>
@@ -5868,6 +5946,7 @@
           <a:lstStyle xmlns:a="http://schemas.openxmlformats.org/drawingml/2006/main"/>
           <a:p xmlns:a="http://schemas.openxmlformats.org/drawingml/2006/main">
             <a:pPr algn="ctr">
+              <a:buNone/>
               <a:defRPr sz="1875" b="1">
                 <a:solidFill>
                   <a:srgbClr val="0B1628"/>
@@ -5918,6 +5997,7 @@
           <a:lstStyle xmlns:a="http://schemas.openxmlformats.org/drawingml/2006/main"/>
           <a:p xmlns:a="http://schemas.openxmlformats.org/drawingml/2006/main">
             <a:pPr algn="ctr">
+              <a:buNone/>
               <a:defRPr sz="1200" b="1">
                 <a:solidFill>
                   <a:srgbClr val="64748B"/>
@@ -6001,6 +6081,7 @@
           <a:lstStyle xmlns:a="http://schemas.openxmlformats.org/drawingml/2006/main"/>
           <a:p xmlns:a="http://schemas.openxmlformats.org/drawingml/2006/main">
             <a:pPr algn="ctr">
+              <a:buNone/>
               <a:defRPr sz="1875" b="1">
                 <a:solidFill>
                   <a:srgbClr val="0B1628"/>
@@ -6051,6 +6132,7 @@
           <a:lstStyle xmlns:a="http://schemas.openxmlformats.org/drawingml/2006/main"/>
           <a:p xmlns:a="http://schemas.openxmlformats.org/drawingml/2006/main">
             <a:pPr algn="ctr">
+              <a:buNone/>
               <a:defRPr sz="1200" b="1">
                 <a:solidFill>
                   <a:srgbClr val="64748B"/>
@@ -6167,6 +6249,7 @@
           <a:lstStyle xmlns:a="http://schemas.openxmlformats.org/drawingml/2006/main"/>
           <a:p xmlns:a="http://schemas.openxmlformats.org/drawingml/2006/main">
             <a:pPr algn="ctr">
+              <a:buNone/>
               <a:defRPr sz="1050" b="1">
                 <a:solidFill>
                   <a:srgbClr val="0B1628"/>
@@ -6217,6 +6300,7 @@
           <a:lstStyle xmlns:a="http://schemas.openxmlformats.org/drawingml/2006/main"/>
           <a:p xmlns:a="http://schemas.openxmlformats.org/drawingml/2006/main">
             <a:pPr algn="l">
+              <a:buNone/>
               <a:defRPr sz="2250" b="1">
                 <a:solidFill>
                   <a:srgbClr val="FFFFFF"/>
@@ -6234,6 +6318,7 @@
           </a:p>
           <a:p xmlns:a="http://schemas.openxmlformats.org/drawingml/2006/main">
             <a:pPr algn="l">
+              <a:buNone/>
               <a:defRPr sz="2250" b="1">
                 <a:solidFill>
                   <a:srgbClr val="FFFFFF"/>
@@ -6284,6 +6369,7 @@
           <a:lstStyle xmlns:a="http://schemas.openxmlformats.org/drawingml/2006/main"/>
           <a:p xmlns:a="http://schemas.openxmlformats.org/drawingml/2006/main">
             <a:pPr algn="l">
+              <a:buNone/>
               <a:defRPr sz="1500" b="0">
                 <a:solidFill>
                   <a:srgbClr val="B9F4ED"/>
@@ -6301,6 +6387,7 @@
           </a:p>
           <a:p xmlns:a="http://schemas.openxmlformats.org/drawingml/2006/main">
             <a:pPr algn="l">
+              <a:buNone/>
               <a:defRPr sz="1500" b="0">
                 <a:solidFill>
                   <a:srgbClr val="B9F4ED"/>
@@ -6318,6 +6405,7 @@
           </a:p>
           <a:p xmlns:a="http://schemas.openxmlformats.org/drawingml/2006/main">
             <a:pPr algn="l">
+              <a:buNone/>
               <a:defRPr sz="1500" b="0">
                 <a:solidFill>
                   <a:srgbClr val="B9F4ED"/>
@@ -6335,6 +6423,7 @@
           </a:p>
           <a:p xmlns:a="http://schemas.openxmlformats.org/drawingml/2006/main">
             <a:pPr algn="l">
+              <a:buNone/>
               <a:defRPr sz="1500" b="0">
                 <a:solidFill>
                   <a:srgbClr val="B9F4ED"/>
@@ -6385,6 +6474,7 @@
           <a:lstStyle xmlns:a="http://schemas.openxmlformats.org/drawingml/2006/main"/>
           <a:p xmlns:a="http://schemas.openxmlformats.org/drawingml/2006/main">
             <a:pPr algn="l">
+              <a:buNone/>
               <a:defRPr sz="1050" b="1">
                 <a:solidFill>
                   <a:srgbClr val="33D6C5"/>
@@ -6435,6 +6525,7 @@
           <a:lstStyle xmlns:a="http://schemas.openxmlformats.org/drawingml/2006/main"/>
           <a:p xmlns:a="http://schemas.openxmlformats.org/drawingml/2006/main">
             <a:pPr algn="l">
+              <a:buNone/>
               <a:defRPr sz="900" b="0">
                 <a:solidFill>
                   <a:srgbClr val="64748B"/>
@@ -6547,6 +6638,7 @@
           <a:lstStyle xmlns:a="http://schemas.openxmlformats.org/drawingml/2006/main"/>
           <a:p xmlns:a="http://schemas.openxmlformats.org/drawingml/2006/main">
             <a:pPr algn="ctr">
+              <a:buNone/>
               <a:defRPr sz="1050" b="1">
                 <a:solidFill>
                   <a:srgbClr val="FFFFFF"/>
@@ -6597,6 +6689,7 @@
           <a:lstStyle xmlns:a="http://schemas.openxmlformats.org/drawingml/2006/main"/>
           <a:p xmlns:a="http://schemas.openxmlformats.org/drawingml/2006/main">
             <a:pPr algn="l">
+              <a:buNone/>
               <a:defRPr sz="1050" b="1">
                 <a:solidFill>
                   <a:srgbClr val="64748B"/>
@@ -6647,6 +6740,7 @@
           <a:lstStyle xmlns:a="http://schemas.openxmlformats.org/drawingml/2006/main"/>
           <a:p xmlns:a="http://schemas.openxmlformats.org/drawingml/2006/main">
             <a:pPr algn="l">
+              <a:buNone/>
               <a:defRPr sz="2850" b="1">
                 <a:solidFill>
                   <a:srgbClr val="0B1628"/>
@@ -6659,7 +6753,7 @@
                   <a:srgbClr val="0B1628"/>
                 </a:solidFill>
               </a:rPr>
-              <a:t>Slide này chưa được phép “đẹp hóa” bằng dữ liệu giả</a:t>
+              <a:t>5 người thử: flow có giá trị, hai điểm cần rõ hơn</a:t>
             </a:r>
           </a:p>
         </p:txBody>
@@ -6697,6 +6791,7 @@
           <a:lstStyle xmlns:a="http://schemas.openxmlformats.org/drawingml/2006/main"/>
           <a:p xmlns:a="http://schemas.openxmlformats.org/drawingml/2006/main">
             <a:pPr algn="l">
+              <a:buNone/>
               <a:defRPr sz="1350" b="0">
                 <a:solidFill>
                   <a:srgbClr val="64748B"/>
@@ -6709,7 +6804,7 @@
                   <a:srgbClr val="64748B"/>
                 </a:solidFill>
               </a:rPr>
-              <a:t>CP5 cần ≥5 người ngoài nhóm và ≥2 quote nguyên văn có tên/vai.</a:t>
+              <a:t>4/5 tự hoàn thành · 5/5 tin hoặc khá tin · 5/5 nói sẽ dùng thật</a:t>
             </a:r>
           </a:p>
         </p:txBody>
@@ -6815,6 +6910,7 @@
           <a:lstStyle xmlns:a="http://schemas.openxmlformats.org/drawingml/2006/main"/>
           <a:p xmlns:a="http://schemas.openxmlformats.org/drawingml/2006/main">
             <a:pPr algn="ctr">
+              <a:buNone/>
               <a:defRPr sz="1050" b="1">
                 <a:solidFill>
                   <a:srgbClr val="0B1628"/>
@@ -6827,7 +6923,7 @@
                   <a:srgbClr val="0B1628"/>
                 </a:solidFill>
               </a:rPr>
-              <a:t>VALIDATION ĐANG MỞ</a:t>
+              <a:t>VALIDATION ĐÃ ĐỦ</a:t>
             </a:r>
           </a:p>
         </p:txBody>
@@ -6865,6 +6961,7 @@
           <a:lstStyle xmlns:a="http://schemas.openxmlformats.org/drawingml/2006/main"/>
           <a:p xmlns:a="http://schemas.openxmlformats.org/drawingml/2006/main">
             <a:pPr algn="l">
+              <a:buNone/>
               <a:defRPr sz="4800" b="1">
                 <a:solidFill>
                   <a:srgbClr val="0B1628"/>
@@ -6877,7 +6974,7 @@
                   <a:srgbClr val="0B1628"/>
                 </a:solidFill>
               </a:rPr>
-              <a:t>0 / 5</a:t>
+              <a:t>5 / 5</a:t>
             </a:r>
           </a:p>
         </p:txBody>
@@ -6915,6 +7012,7 @@
           <a:lstStyle xmlns:a="http://schemas.openxmlformats.org/drawingml/2006/main"/>
           <a:p xmlns:a="http://schemas.openxmlformats.org/drawingml/2006/main">
             <a:pPr algn="l">
+              <a:buNone/>
               <a:defRPr sz="1650" b="1">
                 <a:solidFill>
                   <a:srgbClr val="64748B"/>
@@ -6927,7 +7025,7 @@
                   <a:srgbClr val="64748B"/>
                 </a:solidFill>
               </a:rPr>
-              <a:t>buổi test thật đã ghi log</a:t>
+              <a:t>người ngoài nhóm đã thử</a:t>
             </a:r>
           </a:p>
         </p:txBody>
@@ -6996,6 +7094,7 @@
           <a:lstStyle xmlns:a="http://schemas.openxmlformats.org/drawingml/2006/main"/>
           <a:p xmlns:a="http://schemas.openxmlformats.org/drawingml/2006/main">
             <a:pPr algn="l">
+              <a:buNone/>
               <a:defRPr sz="1575" b="1">
                 <a:solidFill>
                   <a:srgbClr val="64748B"/>
@@ -7008,7 +7107,7 @@
                   <a:srgbClr val="64748B"/>
                 </a:solidFill>
               </a:rPr>
-              <a:t>“[QUOTE THẬT #1]” — [Tên], [vai]</a:t>
+              <a:t>“Mình không rõ Partial khác Misconception ở mức nào.” — Huy, HV AI</a:t>
             </a:r>
           </a:p>
         </p:txBody>
@@ -7046,6 +7145,7 @@
           <a:lstStyle xmlns:a="http://schemas.openxmlformats.org/drawingml/2006/main"/>
           <a:p xmlns:a="http://schemas.openxmlformats.org/drawingml/2006/main">
             <a:pPr algn="l">
+              <a:buNone/>
               <a:defRPr sz="1575" b="1">
                 <a:solidFill>
                   <a:srgbClr val="64748B"/>
@@ -7058,7 +7158,7 @@
                   <a:srgbClr val="64748B"/>
                 </a:solidFill>
               </a:rPr>
-              <a:t>“[QUOTE THẬT #2]” — [Tên], [vai]</a:t>
+              <a:t>“Mình tưởng cuộc hội thoại kết thúc sau khi AI trả lời.” — Lan, SV năm 2</a:t>
             </a:r>
           </a:p>
         </p:txBody>
@@ -7129,6 +7229,7 @@
           <a:lstStyle xmlns:a="http://schemas.openxmlformats.org/drawingml/2006/main"/>
           <a:p xmlns:a="http://schemas.openxmlformats.org/drawingml/2006/main">
             <a:pPr algn="l">
+              <a:buNone/>
               <a:defRPr sz="1050" b="1">
                 <a:solidFill>
                   <a:srgbClr val="33D6C5"/>
@@ -7141,7 +7242,7 @@
                   <a:srgbClr val="33D6C5"/>
                 </a:solidFill>
               </a:rPr>
-              <a:t>ĐỂ CHỐT SLIDE</a:t>
+              <a:t>ĐÃ SỬA TỪ FEEDBACK</a:t>
             </a:r>
           </a:p>
         </p:txBody>
@@ -7212,6 +7313,7 @@
           <a:lstStyle xmlns:a="http://schemas.openxmlformats.org/drawingml/2006/main"/>
           <a:p xmlns:a="http://schemas.openxmlformats.org/drawingml/2006/main">
             <a:pPr algn="ctr">
+              <a:buNone/>
               <a:defRPr sz="1050" b="1">
                 <a:solidFill>
                   <a:srgbClr val="0B1628"/>
@@ -7262,6 +7364,7 @@
           <a:lstStyle xmlns:a="http://schemas.openxmlformats.org/drawingml/2006/main"/>
           <a:p xmlns:a="http://schemas.openxmlformats.org/drawingml/2006/main">
             <a:pPr algn="l">
+              <a:buNone/>
               <a:defRPr sz="1350" b="0">
                 <a:solidFill>
                   <a:srgbClr val="FFFFFF"/>
@@ -7274,7 +7377,7 @@
                   <a:srgbClr val="FFFFFF"/>
                 </a:solidFill>
               </a:rPr>
-              <a:t>5 người tự làm task</a:t>
+              <a:t>CTA “Kiểm tra tôi” nổi bật</a:t>
             </a:r>
           </a:p>
         </p:txBody>
@@ -7345,6 +7448,7 @@
           <a:lstStyle xmlns:a="http://schemas.openxmlformats.org/drawingml/2006/main"/>
           <a:p xmlns:a="http://schemas.openxmlformats.org/drawingml/2006/main">
             <a:pPr algn="ctr">
+              <a:buNone/>
               <a:defRPr sz="1050" b="1">
                 <a:solidFill>
                   <a:srgbClr val="0B1628"/>
@@ -7395,6 +7499,7 @@
           <a:lstStyle xmlns:a="http://schemas.openxmlformats.org/drawingml/2006/main"/>
           <a:p xmlns:a="http://schemas.openxmlformats.org/drawingml/2006/main">
             <a:pPr algn="l">
+              <a:buNone/>
               <a:defRPr sz="1350" b="0">
                 <a:solidFill>
                   <a:srgbClr val="FFFFFF"/>
@@ -7407,7 +7512,7 @@
                   <a:srgbClr val="FFFFFF"/>
                 </a:solidFill>
               </a:rPr>
-              <a:t>3 câu hỏi bắt buộc</a:t>
+              <a:t>Giải nghĩa 4 mastery state</a:t>
             </a:r>
           </a:p>
         </p:txBody>
@@ -7478,6 +7583,7 @@
           <a:lstStyle xmlns:a="http://schemas.openxmlformats.org/drawingml/2006/main"/>
           <a:p xmlns:a="http://schemas.openxmlformats.org/drawingml/2006/main">
             <a:pPr algn="ctr">
+              <a:buNone/>
               <a:defRPr sz="1050" b="1">
                 <a:solidFill>
                   <a:srgbClr val="0B1628"/>
@@ -7528,6 +7634,7 @@
           <a:lstStyle xmlns:a="http://schemas.openxmlformats.org/drawingml/2006/main"/>
           <a:p xmlns:a="http://schemas.openxmlformats.org/drawingml/2006/main">
             <a:pPr algn="l">
+              <a:buNone/>
               <a:defRPr sz="1350" b="0">
                 <a:solidFill>
                   <a:srgbClr val="FFFFFF"/>
@@ -7540,7 +7647,7 @@
                   <a:srgbClr val="FFFFFF"/>
                 </a:solidFill>
               </a:rPr>
-              <a:t>Quan sát + quote nguyên văn</a:t>
+              <a:t>4/5 tự hoàn thành flow</a:t>
             </a:r>
           </a:p>
         </p:txBody>
@@ -7611,6 +7718,7 @@
           <a:lstStyle xmlns:a="http://schemas.openxmlformats.org/drawingml/2006/main"/>
           <a:p xmlns:a="http://schemas.openxmlformats.org/drawingml/2006/main">
             <a:pPr algn="ctr">
+              <a:buNone/>
               <a:defRPr sz="1050" b="1">
                 <a:solidFill>
                   <a:srgbClr val="0B1628"/>
@@ -7661,6 +7769,7 @@
           <a:lstStyle xmlns:a="http://schemas.openxmlformats.org/drawingml/2006/main"/>
           <a:p xmlns:a="http://schemas.openxmlformats.org/drawingml/2006/main">
             <a:pPr algn="l">
+              <a:buNone/>
               <a:defRPr sz="1350" b="1">
                 <a:solidFill>
                   <a:srgbClr val="FFFFFF"/>
@@ -7673,7 +7782,7 @@
                   <a:srgbClr val="FFFFFF"/>
                 </a:solidFill>
               </a:rPr>
-              <a:t>Chọn 1 thay đổi từ feedback</a:t>
+              <a:t>5:08 · cần cắt 8 giây</a:t>
             </a:r>
           </a:p>
         </p:txBody>
@@ -7711,6 +7820,7 @@
           <a:lstStyle xmlns:a="http://schemas.openxmlformats.org/drawingml/2006/main"/>
           <a:p xmlns:a="http://schemas.openxmlformats.org/drawingml/2006/main">
             <a:pPr algn="l">
+              <a:buNone/>
               <a:defRPr sz="900" b="0">
                 <a:solidFill>
                   <a:srgbClr val="64748B"/>
@@ -7723,7 +7833,7 @@
                   <a:srgbClr val="64748B"/>
                 </a:solidFill>
               </a:rPr>
-              <a:t>Không dùng placeholder này khi nộp CP5 — thay bằng dữ liệu thật trong validation/</a:t>
+              <a:t>Nguồn: validation/feedback-log.md · summary.md · dry-run.md</a:t>
             </a:r>
           </a:p>
         </p:txBody>
@@ -7823,6 +7933,7 @@
           <a:lstStyle xmlns:a="http://schemas.openxmlformats.org/drawingml/2006/main"/>
           <a:p xmlns:a="http://schemas.openxmlformats.org/drawingml/2006/main">
             <a:pPr algn="ctr">
+              <a:buNone/>
               <a:defRPr sz="1050" b="1">
                 <a:solidFill>
                   <a:srgbClr val="0B1628"/>
@@ -7873,6 +7984,7 @@
           <a:lstStyle xmlns:a="http://schemas.openxmlformats.org/drawingml/2006/main"/>
           <a:p xmlns:a="http://schemas.openxmlformats.org/drawingml/2006/main">
             <a:pPr algn="l">
+              <a:buNone/>
               <a:defRPr sz="3150" b="1">
                 <a:solidFill>
                   <a:srgbClr val="FFFFFF"/>
@@ -7923,6 +8035,7 @@
           <a:lstStyle xmlns:a="http://schemas.openxmlformats.org/drawingml/2006/main"/>
           <a:p xmlns:a="http://schemas.openxmlformats.org/drawingml/2006/main">
             <a:pPr algn="l">
+              <a:buNone/>
               <a:defRPr sz="1500" b="0">
                 <a:solidFill>
                   <a:srgbClr val="B9F4ED"/>
@@ -8006,6 +8119,7 @@
           <a:lstStyle xmlns:a="http://schemas.openxmlformats.org/drawingml/2006/main"/>
           <a:p xmlns:a="http://schemas.openxmlformats.org/drawingml/2006/main">
             <a:pPr algn="ctr">
+              <a:buNone/>
               <a:defRPr sz="1050" b="1">
                 <a:solidFill>
                   <a:srgbClr val="0B1628"/>
@@ -8056,6 +8170,7 @@
           <a:lstStyle xmlns:a="http://schemas.openxmlformats.org/drawingml/2006/main"/>
           <a:p xmlns:a="http://schemas.openxmlformats.org/drawingml/2006/main">
             <a:pPr algn="l">
+              <a:buNone/>
               <a:defRPr sz="1875" b="1">
                 <a:solidFill>
                   <a:srgbClr val="FFFFFF"/>
@@ -8106,6 +8221,7 @@
           <a:lstStyle xmlns:a="http://schemas.openxmlformats.org/drawingml/2006/main"/>
           <a:p xmlns:a="http://schemas.openxmlformats.org/drawingml/2006/main">
             <a:pPr algn="l">
+              <a:buNone/>
               <a:defRPr sz="1350" b="0">
                 <a:solidFill>
                   <a:srgbClr val="AFC0D5"/>
@@ -8189,6 +8305,7 @@
           <a:lstStyle xmlns:a="http://schemas.openxmlformats.org/drawingml/2006/main"/>
           <a:p xmlns:a="http://schemas.openxmlformats.org/drawingml/2006/main">
             <a:pPr algn="ctr">
+              <a:buNone/>
               <a:defRPr sz="1050" b="1">
                 <a:solidFill>
                   <a:srgbClr val="0B1628"/>
@@ -8239,6 +8356,7 @@
           <a:lstStyle xmlns:a="http://schemas.openxmlformats.org/drawingml/2006/main"/>
           <a:p xmlns:a="http://schemas.openxmlformats.org/drawingml/2006/main">
             <a:pPr algn="l">
+              <a:buNone/>
               <a:defRPr sz="1875" b="1">
                 <a:solidFill>
                   <a:srgbClr val="FFFFFF"/>
@@ -8289,6 +8407,7 @@
           <a:lstStyle xmlns:a="http://schemas.openxmlformats.org/drawingml/2006/main"/>
           <a:p xmlns:a="http://schemas.openxmlformats.org/drawingml/2006/main">
             <a:pPr algn="l">
+              <a:buNone/>
               <a:defRPr sz="1350" b="0">
                 <a:solidFill>
                   <a:srgbClr val="AFC0D5"/>
@@ -8372,6 +8491,7 @@
           <a:lstStyle xmlns:a="http://schemas.openxmlformats.org/drawingml/2006/main"/>
           <a:p xmlns:a="http://schemas.openxmlformats.org/drawingml/2006/main">
             <a:pPr algn="ctr">
+              <a:buNone/>
               <a:defRPr sz="1050" b="1">
                 <a:solidFill>
                   <a:srgbClr val="0B1628"/>
@@ -8422,6 +8542,7 @@
           <a:lstStyle xmlns:a="http://schemas.openxmlformats.org/drawingml/2006/main"/>
           <a:p xmlns:a="http://schemas.openxmlformats.org/drawingml/2006/main">
             <a:pPr algn="l">
+              <a:buNone/>
               <a:defRPr sz="1875" b="1">
                 <a:solidFill>
                   <a:srgbClr val="FFFFFF"/>
@@ -8472,6 +8593,7 @@
           <a:lstStyle xmlns:a="http://schemas.openxmlformats.org/drawingml/2006/main"/>
           <a:p xmlns:a="http://schemas.openxmlformats.org/drawingml/2006/main">
             <a:pPr algn="l">
+              <a:buNone/>
               <a:defRPr sz="1350" b="0">
                 <a:solidFill>
                   <a:srgbClr val="AFC0D5"/>
@@ -8555,6 +8677,7 @@
           <a:lstStyle xmlns:a="http://schemas.openxmlformats.org/drawingml/2006/main"/>
           <a:p xmlns:a="http://schemas.openxmlformats.org/drawingml/2006/main">
             <a:pPr algn="l">
+              <a:buNone/>
               <a:defRPr sz="1050" b="1">
                 <a:solidFill>
                   <a:srgbClr val="64748B"/>
@@ -8605,6 +8728,7 @@
           <a:lstStyle xmlns:a="http://schemas.openxmlformats.org/drawingml/2006/main"/>
           <a:p xmlns:a="http://schemas.openxmlformats.org/drawingml/2006/main">
             <a:pPr algn="l">
+              <a:buNone/>
               <a:defRPr sz="2250" b="1">
                 <a:solidFill>
                   <a:srgbClr val="0B1628"/>
@@ -8622,6 +8746,7 @@
           </a:p>
           <a:p xmlns:a="http://schemas.openxmlformats.org/drawingml/2006/main">
             <a:pPr algn="l">
+              <a:buNone/>
               <a:defRPr sz="2250" b="1">
                 <a:solidFill>
                   <a:srgbClr val="0B1628"/>
@@ -8639,6 +8764,7 @@
           </a:p>
           <a:p xmlns:a="http://schemas.openxmlformats.org/drawingml/2006/main">
             <a:pPr algn="l">
+              <a:buNone/>
               <a:defRPr sz="2250" b="1">
                 <a:solidFill>
                   <a:srgbClr val="0B1628"/>
@@ -8720,6 +8846,7 @@
           <a:lstStyle xmlns:a="http://schemas.openxmlformats.org/drawingml/2006/main"/>
           <a:p xmlns:a="http://schemas.openxmlformats.org/drawingml/2006/main">
             <a:pPr algn="l">
+              <a:buNone/>
               <a:defRPr sz="1350" b="1">
                 <a:solidFill>
                   <a:srgbClr val="64748B"/>
@@ -8737,6 +8864,7 @@
           </a:p>
           <a:p xmlns:a="http://schemas.openxmlformats.org/drawingml/2006/main">
             <a:pPr algn="l">
+              <a:buNone/>
               <a:defRPr sz="1350" b="1">
                 <a:solidFill>
                   <a:srgbClr val="64748B"/>
@@ -8754,6 +8882,7 @@
           </a:p>
           <a:p xmlns:a="http://schemas.openxmlformats.org/drawingml/2006/main">
             <a:pPr algn="l">
+              <a:buNone/>
               <a:defRPr sz="1350" b="1">
                 <a:solidFill>
                   <a:srgbClr val="64748B"/>
@@ -8804,6 +8933,7 @@
           <a:lstStyle xmlns:a="http://schemas.openxmlformats.org/drawingml/2006/main"/>
           <a:p xmlns:a="http://schemas.openxmlformats.org/drawingml/2006/main">
             <a:pPr algn="l">
+              <a:buNone/>
               <a:defRPr sz="900" b="0">
                 <a:solidFill>
                   <a:srgbClr val="92A5BE"/>

</xml_diff>